<commit_message>
fix(build_slides): short explanations stay above their table; tables use more of the band
Co-Authored-By: Claude Opus 5.5 <noreply@anthropic.com>
</commit_message>
<xml_diff>
--- a/projects/drug-information-practical/slides/ch05-protocol-hypothesis-ethics.pptx
+++ b/projects/drug-information-practical/slides/ch05-protocol-hypothesis-ethics.pptx
@@ -19979,7 +19979,7 @@
                     <a:lstStyle/>
                     <a:p>
                       <a:r>
-                        <a:rPr sz="1400" i="0" b="1">
+                        <a:rPr sz="1700" i="0" b="1">
                           <a:solidFill>
                             <a:srgbClr val="FFFFFF"/>
                           </a:solidFill>
@@ -20001,7 +20001,7 @@
                     <a:lstStyle/>
                     <a:p>
                       <a:r>
-                        <a:rPr sz="1400" i="0" b="1">
+                        <a:rPr sz="1700" i="0" b="1">
                           <a:solidFill>
                             <a:srgbClr val="FFFFFF"/>
                           </a:solidFill>
@@ -20025,7 +20025,7 @@
                     <a:lstStyle/>
                     <a:p>
                       <a:r>
-                        <a:rPr sz="1500" i="0" b="1">
+                        <a:rPr sz="1800" i="0" b="1">
                           <a:solidFill>
                             <a:srgbClr val="2B211C"/>
                           </a:solidFill>
@@ -20047,7 +20047,7 @@
                     <a:lstStyle/>
                     <a:p>
                       <a:r>
-                        <a:rPr sz="1500" i="0" b="0">
+                        <a:rPr sz="1800" i="0" b="0">
                           <a:solidFill>
                             <a:srgbClr val="2B211C"/>
                           </a:solidFill>
@@ -20071,7 +20071,7 @@
                     <a:lstStyle/>
                     <a:p>
                       <a:r>
-                        <a:rPr sz="1500" i="0" b="1">
+                        <a:rPr sz="1800" i="0" b="1">
                           <a:solidFill>
                             <a:srgbClr val="2B211C"/>
                           </a:solidFill>
@@ -20093,7 +20093,7 @@
                     <a:lstStyle/>
                     <a:p>
                       <a:r>
-                        <a:rPr sz="1500" i="0" b="0">
+                        <a:rPr sz="1800" i="0" b="0">
                           <a:solidFill>
                             <a:srgbClr val="2B211C"/>
                           </a:solidFill>
@@ -20117,7 +20117,7 @@
                     <a:lstStyle/>
                     <a:p>
                       <a:r>
-                        <a:rPr sz="1500" i="0" b="1">
+                        <a:rPr sz="1800" i="0" b="1">
                           <a:solidFill>
                             <a:srgbClr val="2B211C"/>
                           </a:solidFill>
@@ -20139,7 +20139,7 @@
                     <a:lstStyle/>
                     <a:p>
                       <a:r>
-                        <a:rPr sz="1500" i="0" b="0">
+                        <a:rPr sz="1800" i="0" b="0">
                           <a:solidFill>
                             <a:srgbClr val="2B211C"/>
                           </a:solidFill>
@@ -20163,7 +20163,7 @@
                     <a:lstStyle/>
                     <a:p>
                       <a:r>
-                        <a:rPr sz="1500" i="0" b="1">
+                        <a:rPr sz="1800" i="0" b="1">
                           <a:solidFill>
                             <a:srgbClr val="2B211C"/>
                           </a:solidFill>
@@ -20185,7 +20185,7 @@
                     <a:lstStyle/>
                     <a:p>
                       <a:r>
-                        <a:rPr sz="1500" i="0" b="0">
+                        <a:rPr sz="1800" i="0" b="0">
                           <a:solidFill>
                             <a:srgbClr val="2B211C"/>
                           </a:solidFill>
@@ -20209,7 +20209,7 @@
                     <a:lstStyle/>
                     <a:p>
                       <a:r>
-                        <a:rPr sz="1500" i="0" b="1">
+                        <a:rPr sz="1800" i="0" b="1">
                           <a:solidFill>
                             <a:srgbClr val="2B211C"/>
                           </a:solidFill>
@@ -20231,7 +20231,7 @@
                     <a:lstStyle/>
                     <a:p>
                       <a:r>
-                        <a:rPr sz="1500" i="0" b="0">
+                        <a:rPr sz="1800" i="0" b="0">
                           <a:solidFill>
                             <a:srgbClr val="2B211C"/>
                           </a:solidFill>
@@ -20255,7 +20255,7 @@
                     <a:lstStyle/>
                     <a:p>
                       <a:r>
-                        <a:rPr sz="1500" i="0" b="1">
+                        <a:rPr sz="1800" i="0" b="1">
                           <a:solidFill>
                             <a:srgbClr val="2B211C"/>
                           </a:solidFill>
@@ -20277,7 +20277,7 @@
                     <a:lstStyle/>
                     <a:p>
                       <a:r>
-                        <a:rPr sz="1500" i="0" b="0">
+                        <a:rPr sz="1800" i="0" b="0">
                           <a:solidFill>
                             <a:srgbClr val="2B211C"/>
                           </a:solidFill>
@@ -20301,7 +20301,7 @@
                     <a:lstStyle/>
                     <a:p>
                       <a:r>
-                        <a:rPr sz="1500" i="0" b="1">
+                        <a:rPr sz="1800" i="0" b="1">
                           <a:solidFill>
                             <a:srgbClr val="2B211C"/>
                           </a:solidFill>
@@ -20323,7 +20323,7 @@
                     <a:lstStyle/>
                     <a:p>
                       <a:r>
-                        <a:rPr sz="1500" i="0" b="0">
+                        <a:rPr sz="1800" i="0" b="0">
                           <a:solidFill>
                             <a:srgbClr val="2B211C"/>
                           </a:solidFill>

</xml_diff>